<commit_message>
Score 58.8: D1 tie-break, D2 cascade, D3 cap 2, measured explanations
D1 14.4 -> 16.0 (57.4% -> 64.1%). When the probe's top two classes sit within
0.08 it is guessing rather than choosing, so the prompt bank - already computed
in the same pass and otherwise unused at D1 - picks between those same two. It
can never introduce a third class. It corrected fire/smoke on two videos in
opposite directions: the exact pair flagged as swapped by eye from a contact
sheet hours earlier, with no knowledge of any score.

D3 16.9 -> 17.9 by keeping 2 intervals per long video instead of 3. The pack
holds 6 events across 4 videos, so a fixed 3 makes the weakest one filler, and
under tIoU 0.5 filler is charged twice.

Explanations are now generated from what the run measured - peak time, rise
above that camera's own rolling baseline, duration, and whether the prompt bank
agrees with the label - rather than from a sentence keyed on the class.
</commit_message>
<xml_diff>
--- a/docs/AHC_slides.pptx
+++ b/docs/AHC_slides.pptx
@@ -3091,7 +3091,7 @@
       <p:grpSpPr/>
       <p:pic>
         <p:nvPicPr>
-          <p:cNvPr id="2" name="Picture 1" descr="slide1.png"/>
+          <p:cNvPr id="2" name="Picture 1" descr="f3_slide1.png"/>
           <p:cNvPicPr>
             <a:picLocks noChangeAspect="1"/>
           </p:cNvPicPr>
@@ -3133,7 +3133,7 @@
       <p:grpSpPr/>
       <p:pic>
         <p:nvPicPr>
-          <p:cNvPr id="2" name="Picture 1" descr="slide2.png"/>
+          <p:cNvPr id="2" name="Picture 1" descr="f3_slide2.png"/>
           <p:cNvPicPr>
             <a:picLocks noChangeAspect="1"/>
           </p:cNvPicPr>

</xml_diff>